<commit_message>
make Fig 1 formatting consistent
</commit_message>
<xml_diff>
--- a/figures/fig1-workflow.pptx
+++ b/figures/fig1-workflow.pptx
@@ -115,6 +115,107 @@
 </p:presentation>
 </file>
 
+<file path=ppt/changesInfos/changesInfo1.xml><?xml version="1.0" encoding="utf-8"?>
+<pc:chgInfo xmlns:a="http://schemas.openxmlformats.org/drawingml/2006/main" xmlns:r="http://schemas.openxmlformats.org/officeDocument/2006/relationships" xmlns:ac="http://schemas.microsoft.com/office/drawing/2013/main/command" xmlns:pc="http://schemas.microsoft.com/office/powerpoint/2013/main/command">
+  <pc:docChgLst>
+    <pc:chgData name="Truong, Kimberly" userId="925efed1-480b-4601-a542-5efebb98d46d" providerId="ADAL" clId="{2B89FEC1-C8C7-42CA-B874-CA36DB621456}"/>
+    <pc:docChg chg="undo redo custSel modSld">
+      <pc:chgData name="Truong, Kimberly" userId="925efed1-480b-4601-a542-5efebb98d46d" providerId="ADAL" clId="{2B89FEC1-C8C7-42CA-B874-CA36DB621456}" dt="2025-04-03T18:38:51.864" v="17" actId="114"/>
+      <pc:docMkLst>
+        <pc:docMk/>
+      </pc:docMkLst>
+      <pc:sldChg chg="addSp delSp modSp mod">
+        <pc:chgData name="Truong, Kimberly" userId="925efed1-480b-4601-a542-5efebb98d46d" providerId="ADAL" clId="{2B89FEC1-C8C7-42CA-B874-CA36DB621456}" dt="2025-04-03T18:38:51.864" v="17" actId="114"/>
+        <pc:sldMkLst>
+          <pc:docMk/>
+          <pc:sldMk cId="312177612" sldId="2969"/>
+        </pc:sldMkLst>
+        <pc:spChg chg="mod">
+          <ac:chgData name="Truong, Kimberly" userId="925efed1-480b-4601-a542-5efebb98d46d" providerId="ADAL" clId="{2B89FEC1-C8C7-42CA-B874-CA36DB621456}" dt="2025-04-03T18:38:33.325" v="16" actId="120"/>
+          <ac:spMkLst>
+            <pc:docMk/>
+            <pc:sldMk cId="312177612" sldId="2969"/>
+            <ac:spMk id="15" creationId="{FAB754F1-85E0-422D-8F7A-B819C89A0AA5}"/>
+          </ac:spMkLst>
+        </pc:spChg>
+        <pc:spChg chg="mod">
+          <ac:chgData name="Truong, Kimberly" userId="925efed1-480b-4601-a542-5efebb98d46d" providerId="ADAL" clId="{2B89FEC1-C8C7-42CA-B874-CA36DB621456}" dt="2025-04-03T18:38:33.325" v="16" actId="120"/>
+          <ac:spMkLst>
+            <pc:docMk/>
+            <pc:sldMk cId="312177612" sldId="2969"/>
+            <ac:spMk id="21" creationId="{91236F16-7D03-A616-78BE-020B10C1213B}"/>
+          </ac:spMkLst>
+        </pc:spChg>
+        <pc:spChg chg="mod">
+          <ac:chgData name="Truong, Kimberly" userId="925efed1-480b-4601-a542-5efebb98d46d" providerId="ADAL" clId="{2B89FEC1-C8C7-42CA-B874-CA36DB621456}" dt="2025-04-03T18:38:33.325" v="16" actId="120"/>
+          <ac:spMkLst>
+            <pc:docMk/>
+            <pc:sldMk cId="312177612" sldId="2969"/>
+            <ac:spMk id="29" creationId="{73DFA4F3-2CA7-9EEA-6D4E-9FC905F9B3C9}"/>
+          </ac:spMkLst>
+        </pc:spChg>
+        <pc:spChg chg="mod">
+          <ac:chgData name="Truong, Kimberly" userId="925efed1-480b-4601-a542-5efebb98d46d" providerId="ADAL" clId="{2B89FEC1-C8C7-42CA-B874-CA36DB621456}" dt="2025-04-03T18:38:33.325" v="16" actId="120"/>
+          <ac:spMkLst>
+            <pc:docMk/>
+            <pc:sldMk cId="312177612" sldId="2969"/>
+            <ac:spMk id="31" creationId="{C3D87C59-F48A-EC45-DF9C-F824CAC6FF58}"/>
+          </ac:spMkLst>
+        </pc:spChg>
+        <pc:spChg chg="mod">
+          <ac:chgData name="Truong, Kimberly" userId="925efed1-480b-4601-a542-5efebb98d46d" providerId="ADAL" clId="{2B89FEC1-C8C7-42CA-B874-CA36DB621456}" dt="2025-04-03T18:38:33.325" v="16" actId="120"/>
+          <ac:spMkLst>
+            <pc:docMk/>
+            <pc:sldMk cId="312177612" sldId="2969"/>
+            <ac:spMk id="39" creationId="{E23DF677-8AE5-1978-C3F5-A1221B5A4E43}"/>
+          </ac:spMkLst>
+        </pc:spChg>
+        <pc:spChg chg="mod">
+          <ac:chgData name="Truong, Kimberly" userId="925efed1-480b-4601-a542-5efebb98d46d" providerId="ADAL" clId="{2B89FEC1-C8C7-42CA-B874-CA36DB621456}" dt="2025-04-03T18:38:51.864" v="17" actId="114"/>
+          <ac:spMkLst>
+            <pc:docMk/>
+            <pc:sldMk cId="312177612" sldId="2969"/>
+            <ac:spMk id="40" creationId="{F14D9770-A517-F5A6-9A10-6319D6A5B643}"/>
+          </ac:spMkLst>
+        </pc:spChg>
+        <pc:spChg chg="mod">
+          <ac:chgData name="Truong, Kimberly" userId="925efed1-480b-4601-a542-5efebb98d46d" providerId="ADAL" clId="{2B89FEC1-C8C7-42CA-B874-CA36DB621456}" dt="2025-04-03T18:38:33.325" v="16" actId="120"/>
+          <ac:spMkLst>
+            <pc:docMk/>
+            <pc:sldMk cId="312177612" sldId="2969"/>
+            <ac:spMk id="49" creationId="{A0391B82-E113-6052-F878-87AC64265015}"/>
+          </ac:spMkLst>
+        </pc:spChg>
+        <pc:spChg chg="mod">
+          <ac:chgData name="Truong, Kimberly" userId="925efed1-480b-4601-a542-5efebb98d46d" providerId="ADAL" clId="{2B89FEC1-C8C7-42CA-B874-CA36DB621456}" dt="2025-04-03T18:38:33.325" v="16" actId="120"/>
+          <ac:spMkLst>
+            <pc:docMk/>
+            <pc:sldMk cId="312177612" sldId="2969"/>
+            <ac:spMk id="78" creationId="{1B938B19-32C4-3727-C4F1-836C830105FC}"/>
+          </ac:spMkLst>
+        </pc:spChg>
+        <pc:graphicFrameChg chg="add del mod">
+          <ac:chgData name="Truong, Kimberly" userId="925efed1-480b-4601-a542-5efebb98d46d" providerId="ADAL" clId="{2B89FEC1-C8C7-42CA-B874-CA36DB621456}" dt="2025-04-03T18:38:18.585" v="14" actId="478"/>
+          <ac:graphicFrameMkLst>
+            <pc:docMk/>
+            <pc:sldMk cId="312177612" sldId="2969"/>
+            <ac:graphicFrameMk id="2" creationId="{E754F15A-A64A-5277-14C8-1F281AB7EDED}"/>
+          </ac:graphicFrameMkLst>
+        </pc:graphicFrameChg>
+        <pc:graphicFrameChg chg="mod">
+          <ac:chgData name="Truong, Kimberly" userId="925efed1-480b-4601-a542-5efebb98d46d" providerId="ADAL" clId="{2B89FEC1-C8C7-42CA-B874-CA36DB621456}" dt="2025-04-03T18:37:17.974" v="5" actId="207"/>
+          <ac:graphicFrameMkLst>
+            <pc:docMk/>
+            <pc:sldMk cId="312177612" sldId="2969"/>
+            <ac:graphicFrameMk id="24" creationId="{EFF69940-0D6D-5518-442B-DBCC36EF3D3C}"/>
+          </ac:graphicFrameMkLst>
+        </pc:graphicFrameChg>
+      </pc:sldChg>
+    </pc:docChg>
+  </pc:docChgLst>
+</pc:chgInfo>
+</file>
+
 <file path=ppt/diagrams/colors1.xml><?xml version="1.0" encoding="utf-8"?>
 <dgm:colorsDef xmlns:dgm="http://schemas.openxmlformats.org/drawingml/2006/diagram" xmlns:a="http://schemas.openxmlformats.org/drawingml/2006/main" uniqueId="urn:microsoft.com/office/officeart/2005/8/colors/accent5_3">
   <dgm:title val=""/>
@@ -1009,11 +1110,18 @@
         <a:lstStyle/>
         <a:p>
           <a:r>
-            <a:rPr lang="en-US" sz="1400" b="0" dirty="0">
-              <a:latin typeface="Avenir Next LT Pro" panose="020B0504020202020204" pitchFamily="34" charset="0"/>
+            <a:rPr lang="en-US" sz="1800" b="0" dirty="0">
+              <a:effectLst>
+                <a:outerShdw blurRad="38100" dist="38100" dir="2700000" algn="tl">
+                  <a:srgbClr val="000000">
+                    <a:alpha val="43137"/>
+                  </a:srgbClr>
+                </a:outerShdw>
+              </a:effectLst>
+              <a:latin typeface="Aptos" panose="020B0004020202020204" pitchFamily="34" charset="0"/>
               <a:cs typeface="Arial" panose="020B0604020202020204" pitchFamily="34" charset="0"/>
             </a:rPr>
-            <a:t> Tier 1 Positive Assessment</a:t>
+            <a:t> 1. Assay Data Compilation</a:t>
           </a:r>
         </a:p>
       </dgm:t>
@@ -1058,11 +1166,18 @@
         <a:lstStyle/>
         <a:p>
           <a:r>
-            <a:rPr lang="en-US" sz="1400" b="0" dirty="0">
-              <a:latin typeface="Avenir Next LT Pro" panose="020B0504020202020204" pitchFamily="34" charset="0"/>
+            <a:rPr lang="en-US" sz="1800" b="0" dirty="0">
+              <a:effectLst>
+                <a:outerShdw blurRad="38100" dist="38100" dir="2700000" algn="tl">
+                  <a:srgbClr val="000000">
+                    <a:alpha val="43137"/>
+                  </a:srgbClr>
+                </a:outerShdw>
+              </a:effectLst>
+              <a:latin typeface="Aptos" panose="020B0004020202020204" pitchFamily="34" charset="0"/>
               <a:cs typeface="Arial" panose="020B0604020202020204" pitchFamily="34" charset="0"/>
             </a:rPr>
-            <a:t>Assessment for Selectivity + Assay Interference</a:t>
+            <a:t>2. Assessment for Selectivity + Assay Interference</a:t>
           </a:r>
         </a:p>
       </dgm:t>
@@ -1107,11 +1222,18 @@
         <a:lstStyle/>
         <a:p>
           <a:r>
-            <a:rPr lang="en-US" sz="1400" b="0" dirty="0">
-              <a:latin typeface="Avenir Next LT Pro" panose="020B0504020202020204" pitchFamily="34" charset="0"/>
+            <a:rPr lang="en-US" sz="1800" b="0" dirty="0">
+              <a:effectLst>
+                <a:outerShdw blurRad="38100" dist="38100" dir="2700000" algn="tl">
+                  <a:srgbClr val="000000">
+                    <a:alpha val="43137"/>
+                  </a:srgbClr>
+                </a:outerShdw>
+              </a:effectLst>
+              <a:latin typeface="Aptos" panose="020B0004020202020204" pitchFamily="34" charset="0"/>
               <a:cs typeface="Arial" panose="020B0604020202020204" pitchFamily="34" charset="0"/>
             </a:rPr>
-            <a:t> Refinement</a:t>
+            <a:t>3. Refinement</a:t>
           </a:r>
         </a:p>
       </dgm:t>
@@ -1156,25 +1278,18 @@
         <a:lstStyle/>
         <a:p>
           <a:r>
-            <a:rPr lang="en-US" sz="1400" b="0" dirty="0">
-              <a:latin typeface="Avenir Next LT Pro" panose="020B0504020202020204" pitchFamily="34" charset="0"/>
+            <a:rPr lang="en-US" sz="1800" b="0" dirty="0">
+              <a:effectLst>
+                <a:outerShdw blurRad="38100" dist="38100" dir="2700000" algn="tl">
+                  <a:srgbClr val="000000">
+                    <a:alpha val="43137"/>
+                  </a:srgbClr>
+                </a:outerShdw>
+              </a:effectLst>
+              <a:latin typeface="Aptos" panose="020B0004020202020204" pitchFamily="34" charset="0"/>
               <a:cs typeface="Arial" panose="020B0604020202020204" pitchFamily="34" charset="0"/>
             </a:rPr>
-            <a:t>Targeted </a:t>
-          </a:r>
-          <a:r>
-            <a:rPr lang="en-US" sz="1400" b="0" dirty="0" err="1">
-              <a:latin typeface="Avenir Next LT Pro" panose="020B0504020202020204" pitchFamily="34" charset="0"/>
-              <a:cs typeface="Arial" panose="020B0604020202020204" pitchFamily="34" charset="0"/>
-            </a:rPr>
-            <a:t>bioactivity:exposure</a:t>
-          </a:r>
-          <a:r>
-            <a:rPr lang="en-US" sz="1400" b="0" dirty="0">
-              <a:latin typeface="Avenir Next LT Pro" panose="020B0504020202020204" pitchFamily="34" charset="0"/>
-              <a:cs typeface="Arial" panose="020B0604020202020204" pitchFamily="34" charset="0"/>
-            </a:rPr>
-            <a:t> ratios</a:t>
+            <a:t>4. Targeted bioactivity: exposure ratios</a:t>
           </a:r>
         </a:p>
       </dgm:t>
@@ -1354,12 +1469,12 @@
         </a:fontRef>
       </dsp:style>
       <dsp:txBody>
-        <a:bodyPr spcFirstLastPara="0" vert="horz" wrap="square" lIns="56007" tIns="18669" rIns="18669" bIns="18669" numCol="1" spcCol="1270" anchor="ctr" anchorCtr="0">
+        <a:bodyPr spcFirstLastPara="0" vert="horz" wrap="square" lIns="72009" tIns="24003" rIns="24003" bIns="24003" numCol="1" spcCol="1270" anchor="ctr" anchorCtr="0">
           <a:noAutofit/>
         </a:bodyPr>
         <a:lstStyle/>
         <a:p>
-          <a:pPr marL="0" lvl="0" indent="0" algn="ctr" defTabSz="622300">
+          <a:pPr marL="0" lvl="0" indent="0" algn="ctr" defTabSz="800100">
             <a:lnSpc>
               <a:spcPct val="90000"/>
             </a:lnSpc>
@@ -1372,11 +1487,18 @@
             <a:buNone/>
           </a:pPr>
           <a:r>
-            <a:rPr lang="en-US" sz="1400" b="0" kern="1200" dirty="0">
-              <a:latin typeface="Avenir Next LT Pro" panose="020B0504020202020204" pitchFamily="34" charset="0"/>
+            <a:rPr lang="en-US" sz="1800" b="0" kern="1200" dirty="0">
+              <a:effectLst>
+                <a:outerShdw blurRad="38100" dist="38100" dir="2700000" algn="tl">
+                  <a:srgbClr val="000000">
+                    <a:alpha val="43137"/>
+                  </a:srgbClr>
+                </a:outerShdw>
+              </a:effectLst>
+              <a:latin typeface="Aptos" panose="020B0004020202020204" pitchFamily="34" charset="0"/>
               <a:cs typeface="Arial" panose="020B0604020202020204" pitchFamily="34" charset="0"/>
             </a:rPr>
-            <a:t> Tier 1 Positive Assessment</a:t>
+            <a:t> 1. Assay Data Compilation</a:t>
           </a:r>
         </a:p>
       </dsp:txBody>
@@ -1430,12 +1552,12 @@
         </a:fontRef>
       </dsp:style>
       <dsp:txBody>
-        <a:bodyPr spcFirstLastPara="0" vert="horz" wrap="square" lIns="56007" tIns="18669" rIns="18669" bIns="18669" numCol="1" spcCol="1270" anchor="ctr" anchorCtr="0">
+        <a:bodyPr spcFirstLastPara="0" vert="horz" wrap="square" lIns="72009" tIns="24003" rIns="24003" bIns="24003" numCol="1" spcCol="1270" anchor="ctr" anchorCtr="0">
           <a:noAutofit/>
         </a:bodyPr>
         <a:lstStyle/>
         <a:p>
-          <a:pPr marL="0" lvl="0" indent="0" algn="ctr" defTabSz="622300">
+          <a:pPr marL="0" lvl="0" indent="0" algn="ctr" defTabSz="800100">
             <a:lnSpc>
               <a:spcPct val="90000"/>
             </a:lnSpc>
@@ -1448,11 +1570,18 @@
             <a:buNone/>
           </a:pPr>
           <a:r>
-            <a:rPr lang="en-US" sz="1400" b="0" kern="1200" dirty="0">
-              <a:latin typeface="Avenir Next LT Pro" panose="020B0504020202020204" pitchFamily="34" charset="0"/>
+            <a:rPr lang="en-US" sz="1800" b="0" kern="1200" dirty="0">
+              <a:effectLst>
+                <a:outerShdw blurRad="38100" dist="38100" dir="2700000" algn="tl">
+                  <a:srgbClr val="000000">
+                    <a:alpha val="43137"/>
+                  </a:srgbClr>
+                </a:outerShdw>
+              </a:effectLst>
+              <a:latin typeface="Aptos" panose="020B0004020202020204" pitchFamily="34" charset="0"/>
               <a:cs typeface="Arial" panose="020B0604020202020204" pitchFamily="34" charset="0"/>
             </a:rPr>
-            <a:t>Assessment for Selectivity + Assay Interference</a:t>
+            <a:t>2. Assessment for Selectivity + Assay Interference</a:t>
           </a:r>
         </a:p>
       </dsp:txBody>
@@ -1506,12 +1635,12 @@
         </a:fontRef>
       </dsp:style>
       <dsp:txBody>
-        <a:bodyPr spcFirstLastPara="0" vert="horz" wrap="square" lIns="56007" tIns="18669" rIns="18669" bIns="18669" numCol="1" spcCol="1270" anchor="ctr" anchorCtr="0">
+        <a:bodyPr spcFirstLastPara="0" vert="horz" wrap="square" lIns="72009" tIns="24003" rIns="24003" bIns="24003" numCol="1" spcCol="1270" anchor="ctr" anchorCtr="0">
           <a:noAutofit/>
         </a:bodyPr>
         <a:lstStyle/>
         <a:p>
-          <a:pPr marL="0" lvl="0" indent="0" algn="ctr" defTabSz="622300">
+          <a:pPr marL="0" lvl="0" indent="0" algn="ctr" defTabSz="800100">
             <a:lnSpc>
               <a:spcPct val="90000"/>
             </a:lnSpc>
@@ -1524,11 +1653,18 @@
             <a:buNone/>
           </a:pPr>
           <a:r>
-            <a:rPr lang="en-US" sz="1400" b="0" kern="1200" dirty="0">
-              <a:latin typeface="Avenir Next LT Pro" panose="020B0504020202020204" pitchFamily="34" charset="0"/>
+            <a:rPr lang="en-US" sz="1800" b="0" kern="1200" dirty="0">
+              <a:effectLst>
+                <a:outerShdw blurRad="38100" dist="38100" dir="2700000" algn="tl">
+                  <a:srgbClr val="000000">
+                    <a:alpha val="43137"/>
+                  </a:srgbClr>
+                </a:outerShdw>
+              </a:effectLst>
+              <a:latin typeface="Aptos" panose="020B0004020202020204" pitchFamily="34" charset="0"/>
               <a:cs typeface="Arial" panose="020B0604020202020204" pitchFamily="34" charset="0"/>
             </a:rPr>
-            <a:t> Refinement</a:t>
+            <a:t>3. Refinement</a:t>
           </a:r>
         </a:p>
       </dsp:txBody>
@@ -1582,12 +1718,12 @@
         </a:fontRef>
       </dsp:style>
       <dsp:txBody>
-        <a:bodyPr spcFirstLastPara="0" vert="horz" wrap="square" lIns="56007" tIns="18669" rIns="18669" bIns="18669" numCol="1" spcCol="1270" anchor="ctr" anchorCtr="0">
+        <a:bodyPr spcFirstLastPara="0" vert="horz" wrap="square" lIns="72009" tIns="24003" rIns="24003" bIns="24003" numCol="1" spcCol="1270" anchor="ctr" anchorCtr="0">
           <a:noAutofit/>
         </a:bodyPr>
         <a:lstStyle/>
         <a:p>
-          <a:pPr marL="0" lvl="0" indent="0" algn="ctr" defTabSz="622300">
+          <a:pPr marL="0" lvl="0" indent="0" algn="ctr" defTabSz="800100">
             <a:lnSpc>
               <a:spcPct val="90000"/>
             </a:lnSpc>
@@ -1600,25 +1736,18 @@
             <a:buNone/>
           </a:pPr>
           <a:r>
-            <a:rPr lang="en-US" sz="1400" b="0" kern="1200" dirty="0">
-              <a:latin typeface="Avenir Next LT Pro" panose="020B0504020202020204" pitchFamily="34" charset="0"/>
+            <a:rPr lang="en-US" sz="1800" b="0" kern="1200" dirty="0">
+              <a:effectLst>
+                <a:outerShdw blurRad="38100" dist="38100" dir="2700000" algn="tl">
+                  <a:srgbClr val="000000">
+                    <a:alpha val="43137"/>
+                  </a:srgbClr>
+                </a:outerShdw>
+              </a:effectLst>
+              <a:latin typeface="Aptos" panose="020B0004020202020204" pitchFamily="34" charset="0"/>
               <a:cs typeface="Arial" panose="020B0604020202020204" pitchFamily="34" charset="0"/>
             </a:rPr>
-            <a:t>Targeted </a:t>
-          </a:r>
-          <a:r>
-            <a:rPr lang="en-US" sz="1400" b="0" kern="1200" dirty="0" err="1">
-              <a:latin typeface="Avenir Next LT Pro" panose="020B0504020202020204" pitchFamily="34" charset="0"/>
-              <a:cs typeface="Arial" panose="020B0604020202020204" pitchFamily="34" charset="0"/>
-            </a:rPr>
-            <a:t>bioactivity:exposure</a:t>
-          </a:r>
-          <a:r>
-            <a:rPr lang="en-US" sz="1400" b="0" kern="1200" dirty="0">
-              <a:latin typeface="Avenir Next LT Pro" panose="020B0504020202020204" pitchFamily="34" charset="0"/>
-              <a:cs typeface="Arial" panose="020B0604020202020204" pitchFamily="34" charset="0"/>
-            </a:rPr>
-            <a:t> ratios</a:t>
+            <a:t>4. Targeted bioactivity: exposure ratios</a:t>
           </a:r>
         </a:p>
       </dsp:txBody>
@@ -3030,7 +3159,7 @@
           <a:p>
             <a:fld id="{CF3D3CB6-AF3F-41A8-820D-FF52D5A0F9BD}" type="datetimeFigureOut">
               <a:rPr lang="en-US" smtClean="0"/>
-              <a:t>3/10/2025</a:t>
+              <a:t>4/3/2025</a:t>
             </a:fld>
             <a:endParaRPr lang="en-US"/>
           </a:p>
@@ -3533,7 +3662,7 @@
           <a:p>
             <a:fld id="{5445729E-DEA5-4458-8279-F005B7149335}" type="datetimeFigureOut">
               <a:rPr lang="en-US" smtClean="0"/>
-              <a:t>3/10/2025</a:t>
+              <a:t>4/3/2025</a:t>
             </a:fld>
             <a:endParaRPr lang="en-US"/>
           </a:p>
@@ -3731,7 +3860,7 @@
           <a:p>
             <a:fld id="{5445729E-DEA5-4458-8279-F005B7149335}" type="datetimeFigureOut">
               <a:rPr lang="en-US" smtClean="0"/>
-              <a:t>3/10/2025</a:t>
+              <a:t>4/3/2025</a:t>
             </a:fld>
             <a:endParaRPr lang="en-US"/>
           </a:p>
@@ -3939,7 +4068,7 @@
           <a:p>
             <a:fld id="{5445729E-DEA5-4458-8279-F005B7149335}" type="datetimeFigureOut">
               <a:rPr lang="en-US" smtClean="0"/>
-              <a:t>3/10/2025</a:t>
+              <a:t>4/3/2025</a:t>
             </a:fld>
             <a:endParaRPr lang="en-US"/>
           </a:p>
@@ -4137,7 +4266,7 @@
           <a:p>
             <a:fld id="{5445729E-DEA5-4458-8279-F005B7149335}" type="datetimeFigureOut">
               <a:rPr lang="en-US" smtClean="0"/>
-              <a:t>3/10/2025</a:t>
+              <a:t>4/3/2025</a:t>
             </a:fld>
             <a:endParaRPr lang="en-US"/>
           </a:p>
@@ -4412,7 +4541,7 @@
           <a:p>
             <a:fld id="{5445729E-DEA5-4458-8279-F005B7149335}" type="datetimeFigureOut">
               <a:rPr lang="en-US" smtClean="0"/>
-              <a:t>3/10/2025</a:t>
+              <a:t>4/3/2025</a:t>
             </a:fld>
             <a:endParaRPr lang="en-US"/>
           </a:p>
@@ -4677,7 +4806,7 @@
           <a:p>
             <a:fld id="{5445729E-DEA5-4458-8279-F005B7149335}" type="datetimeFigureOut">
               <a:rPr lang="en-US" smtClean="0"/>
-              <a:t>3/10/2025</a:t>
+              <a:t>4/3/2025</a:t>
             </a:fld>
             <a:endParaRPr lang="en-US"/>
           </a:p>
@@ -5089,7 +5218,7 @@
           <a:p>
             <a:fld id="{5445729E-DEA5-4458-8279-F005B7149335}" type="datetimeFigureOut">
               <a:rPr lang="en-US" smtClean="0"/>
-              <a:t>3/10/2025</a:t>
+              <a:t>4/3/2025</a:t>
             </a:fld>
             <a:endParaRPr lang="en-US"/>
           </a:p>
@@ -5230,7 +5359,7 @@
           <a:p>
             <a:fld id="{5445729E-DEA5-4458-8279-F005B7149335}" type="datetimeFigureOut">
               <a:rPr lang="en-US" smtClean="0"/>
-              <a:t>3/10/2025</a:t>
+              <a:t>4/3/2025</a:t>
             </a:fld>
             <a:endParaRPr lang="en-US"/>
           </a:p>
@@ -5343,7 +5472,7 @@
           <a:p>
             <a:fld id="{5445729E-DEA5-4458-8279-F005B7149335}" type="datetimeFigureOut">
               <a:rPr lang="en-US" smtClean="0"/>
-              <a:t>3/10/2025</a:t>
+              <a:t>4/3/2025</a:t>
             </a:fld>
             <a:endParaRPr lang="en-US"/>
           </a:p>
@@ -5654,7 +5783,7 @@
           <a:p>
             <a:fld id="{5445729E-DEA5-4458-8279-F005B7149335}" type="datetimeFigureOut">
               <a:rPr lang="en-US" smtClean="0"/>
-              <a:t>3/10/2025</a:t>
+              <a:t>4/3/2025</a:t>
             </a:fld>
             <a:endParaRPr lang="en-US"/>
           </a:p>
@@ -5942,7 +6071,7 @@
           <a:p>
             <a:fld id="{5445729E-DEA5-4458-8279-F005B7149335}" type="datetimeFigureOut">
               <a:rPr lang="en-US" smtClean="0"/>
-              <a:t>3/10/2025</a:t>
+              <a:t>4/3/2025</a:t>
             </a:fld>
             <a:endParaRPr lang="en-US"/>
           </a:p>
@@ -6183,7 +6312,7 @@
           <a:p>
             <a:fld id="{5445729E-DEA5-4458-8279-F005B7149335}" type="datetimeFigureOut">
               <a:rPr lang="en-US" smtClean="0"/>
-              <a:t>3/10/2025</a:t>
+              <a:t>4/3/2025</a:t>
             </a:fld>
             <a:endParaRPr lang="en-US"/>
           </a:p>
@@ -6660,7 +6789,7 @@
             <p:ph idx="1"/>
             <p:extLst>
               <p:ext uri="{D42A27DB-BD31-4B8C-83A1-F6EECF244321}">
-                <p14:modId xmlns:p14="http://schemas.microsoft.com/office/powerpoint/2010/main" val="2061981393"/>
+                <p14:modId xmlns:p14="http://schemas.microsoft.com/office/powerpoint/2010/main" val="2419759159"/>
               </p:ext>
             </p:extLst>
           </p:nvPr>
@@ -6705,34 +6834,34 @@
           <a:p>
             <a:r>
               <a:rPr lang="en-US" sz="1400" dirty="0">
-                <a:latin typeface="Avenir Next LT Pro" panose="020B0504020202020204" pitchFamily="34" charset="0"/>
+                <a:latin typeface="Aptos" panose="020B0004020202020204" pitchFamily="34" charset="0"/>
                 <a:cs typeface="Calibri" panose="020F0502020204030204" pitchFamily="34" charset="0"/>
               </a:rPr>
               <a:t>17 chemicals with no </a:t>
             </a:r>
             <a:r>
               <a:rPr lang="en-US" sz="1400" i="1" dirty="0">
-                <a:latin typeface="Avenir Next LT Pro" panose="020B0504020202020204" pitchFamily="34" charset="0"/>
+                <a:latin typeface="Aptos" panose="020B0004020202020204" pitchFamily="34" charset="0"/>
                 <a:cs typeface="Calibri" panose="020F0502020204030204" pitchFamily="34" charset="0"/>
               </a:rPr>
               <a:t>in vitro </a:t>
             </a:r>
             <a:r>
               <a:rPr lang="en-US" sz="1400" dirty="0">
-                <a:latin typeface="Avenir Next LT Pro" panose="020B0504020202020204" pitchFamily="34" charset="0"/>
+                <a:latin typeface="Aptos" panose="020B0004020202020204" pitchFamily="34" charset="0"/>
                 <a:cs typeface="Calibri" panose="020F0502020204030204" pitchFamily="34" charset="0"/>
               </a:rPr>
               <a:t>toxicokinetic parameters for </a:t>
             </a:r>
             <a:r>
-              <a:rPr lang="en-US" sz="1400" dirty="0" err="1">
-                <a:latin typeface="Avenir Next LT Pro" panose="020B0504020202020204" pitchFamily="34" charset="0"/>
+              <a:rPr lang="en-US" sz="1400" i="1" dirty="0" err="1">
+                <a:latin typeface="Aptos" panose="020B0004020202020204" pitchFamily="34" charset="0"/>
                 <a:cs typeface="Calibri" panose="020F0502020204030204" pitchFamily="34" charset="0"/>
               </a:rPr>
               <a:t>httk</a:t>
             </a:r>
-            <a:endParaRPr lang="en-US" sz="1400" dirty="0">
-              <a:latin typeface="Avenir Next LT Pro" panose="020B0504020202020204" pitchFamily="34" charset="0"/>
+            <a:endParaRPr lang="en-US" sz="1400" i="1" dirty="0">
+              <a:latin typeface="Aptos" panose="020B0004020202020204" pitchFamily="34" charset="0"/>
               <a:cs typeface="Calibri" panose="020F0502020204030204" pitchFamily="34" charset="0"/>
             </a:endParaRPr>
           </a:p>
@@ -6945,7 +7074,7 @@
           <a:p>
             <a:r>
               <a:rPr lang="en-US" sz="1600" dirty="0">
-                <a:latin typeface="Avenir Next LT Pro" panose="020B0504020202020204" pitchFamily="34" charset="0"/>
+                <a:latin typeface="Aptos" panose="020B0004020202020204" pitchFamily="34" charset="0"/>
               </a:rPr>
               <a:t>285 Positive Chemicals</a:t>
             </a:r>
@@ -6981,17 +7110,19 @@
           <a:lstStyle/>
           <a:p>
             <a:r>
-              <a:rPr lang="en-US" dirty="0"/>
+              <a:rPr lang="en-US" dirty="0">
+                <a:latin typeface="Aptos" panose="020B0004020202020204" pitchFamily="34" charset="0"/>
+              </a:rPr>
               <a:t> </a:t>
             </a:r>
             <a:r>
               <a:rPr lang="en-US" sz="1600" dirty="0">
-                <a:latin typeface="Avenir Next LT Pro" panose="020B0504020202020204" pitchFamily="34" charset="0"/>
+                <a:latin typeface="Aptos" panose="020B0004020202020204" pitchFamily="34" charset="0"/>
               </a:rPr>
               <a:t>135 Chemicals</a:t>
             </a:r>
             <a:endParaRPr lang="en-US" dirty="0">
-              <a:latin typeface="Avenir Next LT Pro" panose="020B0504020202020204" pitchFamily="34" charset="0"/>
+              <a:latin typeface="Aptos" panose="020B0004020202020204" pitchFamily="34" charset="0"/>
             </a:endParaRPr>
           </a:p>
         </p:txBody>
@@ -7026,7 +7157,7 @@
           <a:p>
             <a:r>
               <a:rPr lang="en-US" sz="1600" dirty="0">
-                <a:latin typeface="Avenir Next LT Pro" panose="020B0504020202020204" pitchFamily="34" charset="0"/>
+                <a:latin typeface="Aptos" panose="020B0004020202020204" pitchFamily="34" charset="0"/>
               </a:rPr>
               <a:t>120 Chemicals</a:t>
             </a:r>
@@ -7122,7 +7253,7 @@
           <a:p>
             <a:r>
               <a:rPr lang="en-US" sz="1600" dirty="0">
-                <a:latin typeface="Avenir Next LT Pro" panose="020B0504020202020204" pitchFamily="34" charset="0"/>
+                <a:latin typeface="Aptos" panose="020B0004020202020204" pitchFamily="34" charset="0"/>
               </a:rPr>
               <a:t>103 Chemicals</a:t>
             </a:r>
@@ -7143,8 +7274,8 @@
         </p:nvSpPr>
         <p:spPr>
           <a:xfrm>
-            <a:off x="3436849" y="1930928"/>
-            <a:ext cx="2343571" cy="1384995"/>
+            <a:off x="3415325" y="1901626"/>
+            <a:ext cx="2343571" cy="523220"/>
           </a:xfrm>
           <a:prstGeom prst="rect">
             <a:avLst/>
@@ -7157,25 +7288,12 @@
           </a:bodyPr>
           <a:lstStyle/>
           <a:p>
-            <a:pPr marL="342905" indent="-342905">
-              <a:buAutoNum type="arabicPeriod"/>
-            </a:pPr>
+            <a:pPr algn="ctr"/>
             <a:r>
               <a:rPr lang="en-US" sz="1400" dirty="0">
-                <a:latin typeface="Avenir Next LT Pro" panose="020B0504020202020204" pitchFamily="34" charset="0"/>
+                <a:latin typeface="Aptos" panose="020B0004020202020204" pitchFamily="34" charset="0"/>
               </a:rPr>
               <a:t>Verify “selectivity” even for cell-free assays </a:t>
-            </a:r>
-          </a:p>
-          <a:p>
-            <a:pPr marL="342905" indent="-342905">
-              <a:buAutoNum type="arabicPeriod"/>
-            </a:pPr>
-            <a:r>
-              <a:rPr lang="en-US" sz="1400" dirty="0">
-                <a:latin typeface="Avenir Next LT Pro" panose="020B0504020202020204" pitchFamily="34" charset="0"/>
-              </a:rPr>
-              <a:t>Filter for sources of assay interference or pan-activity </a:t>
             </a:r>
           </a:p>
         </p:txBody>
@@ -7208,9 +7326,7 @@
           </a:bodyPr>
           <a:lstStyle/>
           <a:p>
-            <a:pPr marL="285753" indent="-285753" defTabSz="914411">
-              <a:buFont typeface="Arial" panose="020B0604020202020204" pitchFamily="34" charset="0"/>
-              <a:buChar char="•"/>
+            <a:pPr algn="ctr" defTabSz="914411">
               <a:defRPr/>
             </a:pPr>
             <a:r>
@@ -7218,16 +7334,14 @@
                 <a:solidFill>
                   <a:prstClr val="black"/>
                 </a:solidFill>
-                <a:latin typeface="Avenir Next LT Pro" panose="020B0504020202020204" pitchFamily="34" charset="0"/>
+                <a:latin typeface="Aptos" panose="020B0004020202020204" pitchFamily="34" charset="0"/>
                 <a:cs typeface="Calibri" panose="020F0502020204030204" pitchFamily="34" charset="0"/>
               </a:rPr>
               <a:t>49 DIO1 inhibitors, </a:t>
             </a:r>
           </a:p>
           <a:p>
-            <a:pPr marL="285753" indent="-285753" defTabSz="914411">
-              <a:buFont typeface="Arial" panose="020B0604020202020204" pitchFamily="34" charset="0"/>
-              <a:buChar char="•"/>
+            <a:pPr algn="ctr" defTabSz="914411">
               <a:defRPr/>
             </a:pPr>
             <a:r>
@@ -7235,16 +7349,14 @@
                 <a:solidFill>
                   <a:prstClr val="black"/>
                 </a:solidFill>
-                <a:latin typeface="Avenir Next LT Pro" panose="020B0504020202020204" pitchFamily="34" charset="0"/>
+                <a:latin typeface="Aptos" panose="020B0004020202020204" pitchFamily="34" charset="0"/>
                 <a:cs typeface="Calibri" panose="020F0502020204030204" pitchFamily="34" charset="0"/>
               </a:rPr>
               <a:t>55 DIO2 inhibitors, </a:t>
             </a:r>
           </a:p>
           <a:p>
-            <a:pPr marL="285753" indent="-285753" defTabSz="914411">
-              <a:buFont typeface="Arial" panose="020B0604020202020204" pitchFamily="34" charset="0"/>
-              <a:buChar char="•"/>
+            <a:pPr algn="ctr" defTabSz="914411">
               <a:defRPr/>
             </a:pPr>
             <a:r>
@@ -7252,16 +7364,14 @@
                 <a:solidFill>
                   <a:prstClr val="black"/>
                 </a:solidFill>
-                <a:latin typeface="Avenir Next LT Pro" panose="020B0504020202020204" pitchFamily="34" charset="0"/>
+                <a:latin typeface="Aptos" panose="020B0004020202020204" pitchFamily="34" charset="0"/>
                 <a:cs typeface="Calibri" panose="020F0502020204030204" pitchFamily="34" charset="0"/>
               </a:rPr>
               <a:t>79 DIO3 inhibitors, </a:t>
             </a:r>
           </a:p>
           <a:p>
-            <a:pPr marL="285753" indent="-285753" defTabSz="914411">
-              <a:buFont typeface="Arial" panose="020B0604020202020204" pitchFamily="34" charset="0"/>
-              <a:buChar char="•"/>
+            <a:pPr algn="ctr" defTabSz="914411">
               <a:defRPr/>
             </a:pPr>
             <a:r>
@@ -7269,7 +7379,7 @@
                 <a:solidFill>
                   <a:prstClr val="black"/>
                 </a:solidFill>
-                <a:latin typeface="Avenir Next LT Pro" panose="020B0504020202020204" pitchFamily="34" charset="0"/>
+                <a:latin typeface="Aptos" panose="020B0004020202020204" pitchFamily="34" charset="0"/>
                 <a:cs typeface="Calibri" panose="020F0502020204030204" pitchFamily="34" charset="0"/>
               </a:rPr>
               <a:t>12 IYD inhibitors</a:t>
@@ -7291,8 +7401,8 @@
         </p:nvSpPr>
         <p:spPr>
           <a:xfrm>
-            <a:off x="857121" y="1893268"/>
-            <a:ext cx="2315023" cy="523220"/>
+            <a:off x="849984" y="1901626"/>
+            <a:ext cx="2357494" cy="523220"/>
           </a:xfrm>
           <a:prstGeom prst="rect">
             <a:avLst/>
@@ -7308,9 +7418,21 @@
             <a:pPr algn="ctr"/>
             <a:r>
               <a:rPr lang="en-US" sz="1400" dirty="0">
-                <a:latin typeface="Avenir Next LT Pro" panose="020B0504020202020204" pitchFamily="34" charset="0"/>
+                <a:latin typeface="Aptos" panose="020B0004020202020204" pitchFamily="34" charset="0"/>
               </a:rPr>
-              <a:t>2007 total chemicals screened in single conc</a:t>
+              <a:t>2007 total chemicals screened in single-conc (</a:t>
+            </a:r>
+            <a:r>
+              <a:rPr lang="en-US" sz="1400" dirty="0" err="1">
+                <a:latin typeface="Aptos" panose="020B0004020202020204" pitchFamily="34" charset="0"/>
+              </a:rPr>
+              <a:t>sc</a:t>
+            </a:r>
+            <a:r>
+              <a:rPr lang="en-US" sz="1400" dirty="0">
+                <a:latin typeface="Aptos" panose="020B0004020202020204" pitchFamily="34" charset="0"/>
+              </a:rPr>
+              <a:t>)</a:t>
             </a:r>
           </a:p>
         </p:txBody>
@@ -7329,7 +7451,7 @@
         </p:nvSpPr>
         <p:spPr>
           <a:xfrm flipV="1">
-            <a:off x="1915430" y="2450377"/>
+            <a:off x="1915430" y="2486176"/>
             <a:ext cx="198404" cy="173049"/>
           </a:xfrm>
           <a:prstGeom prst="triangle">
@@ -7375,7 +7497,7 @@
         </p:nvSpPr>
         <p:spPr>
           <a:xfrm>
-            <a:off x="842847" y="2654784"/>
+            <a:off x="856946" y="2654784"/>
             <a:ext cx="2343571" cy="738664"/>
           </a:xfrm>
           <a:prstGeom prst="rect">
@@ -7392,7 +7514,7 @@
             <a:pPr algn="ctr"/>
             <a:r>
               <a:rPr lang="en-US" sz="1400" dirty="0">
-                <a:latin typeface="Avenir Next LT Pro" panose="020B0504020202020204" pitchFamily="34" charset="0"/>
+                <a:latin typeface="Aptos" panose="020B0004020202020204" pitchFamily="34" charset="0"/>
               </a:rPr>
               <a:t>523 chemicals with &gt;20% inhibition in at least one assay</a:t>
             </a:r>
@@ -7459,7 +7581,7 @@
         </p:nvSpPr>
         <p:spPr>
           <a:xfrm>
-            <a:off x="842847" y="3639404"/>
+            <a:off x="856946" y="3639404"/>
             <a:ext cx="2343571" cy="523220"/>
           </a:xfrm>
           <a:prstGeom prst="rect">
@@ -7476,9 +7598,9 @@
             <a:pPr algn="ctr"/>
             <a:r>
               <a:rPr lang="en-US" sz="1400" dirty="0">
-                <a:latin typeface="Avenir Next LT Pro" panose="020B0504020202020204" pitchFamily="34" charset="0"/>
+                <a:latin typeface="Aptos" panose="020B0004020202020204" pitchFamily="34" charset="0"/>
               </a:rPr>
-              <a:t>327 chemicals screened in multi-conc </a:t>
+              <a:t>327 chemicals screened in multi-conc (mc) </a:t>
             </a:r>
           </a:p>
         </p:txBody>
@@ -7557,9 +7679,10 @@
           </a:bodyPr>
           <a:lstStyle/>
           <a:p>
+            <a:pPr algn="ctr"/>
             <a:r>
               <a:rPr lang="en-US" sz="1400" dirty="0">
-                <a:latin typeface="Avenir Next LT Pro" panose="020B0504020202020204" pitchFamily="34" charset="0"/>
+                <a:latin typeface="Aptos" panose="020B0004020202020204" pitchFamily="34" charset="0"/>
               </a:rPr>
               <a:t>Prioritization based on maternal-fetal exposure using HTTK</a:t>
             </a:r>
@@ -7736,6 +7859,90 @@
           </a:fontRef>
         </p:style>
       </p:cxnSp>
+      <p:sp>
+        <p:nvSpPr>
+          <p:cNvPr id="77" name="Isosceles Triangle 76">
+            <a:extLst>
+              <a:ext uri="{FF2B5EF4-FFF2-40B4-BE49-F238E27FC236}">
+                <a16:creationId xmlns:a16="http://schemas.microsoft.com/office/drawing/2014/main" id="{242C9CC5-770B-DEAA-D76C-9F1173E32D87}"/>
+              </a:ext>
+            </a:extLst>
+          </p:cNvPr>
+          <p:cNvSpPr/>
+          <p:nvPr/>
+        </p:nvSpPr>
+        <p:spPr>
+          <a:xfrm flipV="1">
+            <a:off x="4476934" y="2507152"/>
+            <a:ext cx="198404" cy="173049"/>
+          </a:xfrm>
+          <a:prstGeom prst="triangle">
+            <a:avLst/>
+          </a:prstGeom>
+        </p:spPr>
+        <p:style>
+          <a:lnRef idx="2">
+            <a:schemeClr val="accent2">
+              <a:shade val="15000"/>
+            </a:schemeClr>
+          </a:lnRef>
+          <a:fillRef idx="1">
+            <a:schemeClr val="accent2"/>
+          </a:fillRef>
+          <a:effectRef idx="0">
+            <a:schemeClr val="accent2"/>
+          </a:effectRef>
+          <a:fontRef idx="minor">
+            <a:schemeClr val="lt1"/>
+          </a:fontRef>
+        </p:style>
+        <p:txBody>
+          <a:bodyPr rtlCol="0" anchor="ctr"/>
+          <a:lstStyle/>
+          <a:p>
+            <a:pPr algn="ctr"/>
+            <a:endParaRPr lang="en-US"/>
+          </a:p>
+        </p:txBody>
+      </p:sp>
+      <p:sp>
+        <p:nvSpPr>
+          <p:cNvPr id="78" name="TextBox 77">
+            <a:extLst>
+              <a:ext uri="{FF2B5EF4-FFF2-40B4-BE49-F238E27FC236}">
+                <a16:creationId xmlns:a16="http://schemas.microsoft.com/office/drawing/2014/main" id="{1B938B19-32C4-3727-C4F1-836C830105FC}"/>
+              </a:ext>
+            </a:extLst>
+          </p:cNvPr>
+          <p:cNvSpPr txBox="1"/>
+          <p:nvPr/>
+        </p:nvSpPr>
+        <p:spPr>
+          <a:xfrm>
+            <a:off x="3443777" y="2762506"/>
+            <a:ext cx="2343571" cy="523220"/>
+          </a:xfrm>
+          <a:prstGeom prst="rect">
+            <a:avLst/>
+          </a:prstGeom>
+          <a:noFill/>
+        </p:spPr>
+        <p:txBody>
+          <a:bodyPr wrap="square" rtlCol="0">
+            <a:spAutoFit/>
+          </a:bodyPr>
+          <a:lstStyle/>
+          <a:p>
+            <a:pPr algn="ctr"/>
+            <a:r>
+              <a:rPr lang="en-US" sz="1400" dirty="0">
+                <a:latin typeface="Aptos" panose="020B0004020202020204" pitchFamily="34" charset="0"/>
+              </a:rPr>
+              <a:t>Filter for sources of assay interference or pan-activity</a:t>
+            </a:r>
+          </a:p>
+        </p:txBody>
+      </p:sp>
     </p:spTree>
     <p:extLst>
       <p:ext uri="{BB962C8B-B14F-4D97-AF65-F5344CB8AC3E}">

</xml_diff>

<commit_message>
switch back to Avenir Next
</commit_message>
<xml_diff>
--- a/figures/fig1-workflow.pptx
+++ b/figures/fig1-workflow.pptx
@@ -120,18 +120,18 @@
   <pc:docChgLst>
     <pc:chgData name="Truong, Kimberly" userId="925efed1-480b-4601-a542-5efebb98d46d" providerId="ADAL" clId="{2B89FEC1-C8C7-42CA-B874-CA36DB621456}"/>
     <pc:docChg chg="undo redo custSel modSld">
-      <pc:chgData name="Truong, Kimberly" userId="925efed1-480b-4601-a542-5efebb98d46d" providerId="ADAL" clId="{2B89FEC1-C8C7-42CA-B874-CA36DB621456}" dt="2025-04-03T18:38:51.864" v="17" actId="114"/>
+      <pc:chgData name="Truong, Kimberly" userId="925efed1-480b-4601-a542-5efebb98d46d" providerId="ADAL" clId="{2B89FEC1-C8C7-42CA-B874-CA36DB621456}" dt="2025-04-03T21:51:27.729" v="38" actId="2085"/>
       <pc:docMkLst>
         <pc:docMk/>
       </pc:docMkLst>
       <pc:sldChg chg="addSp delSp modSp mod">
-        <pc:chgData name="Truong, Kimberly" userId="925efed1-480b-4601-a542-5efebb98d46d" providerId="ADAL" clId="{2B89FEC1-C8C7-42CA-B874-CA36DB621456}" dt="2025-04-03T18:38:51.864" v="17" actId="114"/>
+        <pc:chgData name="Truong, Kimberly" userId="925efed1-480b-4601-a542-5efebb98d46d" providerId="ADAL" clId="{2B89FEC1-C8C7-42CA-B874-CA36DB621456}" dt="2025-04-03T21:51:27.729" v="38" actId="2085"/>
         <pc:sldMkLst>
           <pc:docMk/>
           <pc:sldMk cId="312177612" sldId="2969"/>
         </pc:sldMkLst>
         <pc:spChg chg="mod">
-          <ac:chgData name="Truong, Kimberly" userId="925efed1-480b-4601-a542-5efebb98d46d" providerId="ADAL" clId="{2B89FEC1-C8C7-42CA-B874-CA36DB621456}" dt="2025-04-03T18:38:33.325" v="16" actId="120"/>
+          <ac:chgData name="Truong, Kimberly" userId="925efed1-480b-4601-a542-5efebb98d46d" providerId="ADAL" clId="{2B89FEC1-C8C7-42CA-B874-CA36DB621456}" dt="2025-04-03T21:49:12.719" v="21" actId="12789"/>
           <ac:spMkLst>
             <pc:docMk/>
             <pc:sldMk cId="312177612" sldId="2969"/>
@@ -139,7 +139,39 @@
           </ac:spMkLst>
         </pc:spChg>
         <pc:spChg chg="mod">
-          <ac:chgData name="Truong, Kimberly" userId="925efed1-480b-4601-a542-5efebb98d46d" providerId="ADAL" clId="{2B89FEC1-C8C7-42CA-B874-CA36DB621456}" dt="2025-04-03T18:38:33.325" v="16" actId="120"/>
+          <ac:chgData name="Truong, Kimberly" userId="925efed1-480b-4601-a542-5efebb98d46d" providerId="ADAL" clId="{2B89FEC1-C8C7-42CA-B874-CA36DB621456}" dt="2025-04-03T21:48:21.082" v="18" actId="2711"/>
+          <ac:spMkLst>
+            <pc:docMk/>
+            <pc:sldMk cId="312177612" sldId="2969"/>
+            <ac:spMk id="16" creationId="{BDA81BDF-EE59-006A-8397-64567E2F85D6}"/>
+          </ac:spMkLst>
+        </pc:spChg>
+        <pc:spChg chg="mod">
+          <ac:chgData name="Truong, Kimberly" userId="925efed1-480b-4601-a542-5efebb98d46d" providerId="ADAL" clId="{2B89FEC1-C8C7-42CA-B874-CA36DB621456}" dt="2025-04-03T21:48:21.082" v="18" actId="2711"/>
+          <ac:spMkLst>
+            <pc:docMk/>
+            <pc:sldMk cId="312177612" sldId="2969"/>
+            <ac:spMk id="17" creationId="{CBE42328-7860-4F4C-85FA-58954216A450}"/>
+          </ac:spMkLst>
+        </pc:spChg>
+        <pc:spChg chg="mod">
+          <ac:chgData name="Truong, Kimberly" userId="925efed1-480b-4601-a542-5efebb98d46d" providerId="ADAL" clId="{2B89FEC1-C8C7-42CA-B874-CA36DB621456}" dt="2025-04-03T21:48:21.082" v="18" actId="2711"/>
+          <ac:spMkLst>
+            <pc:docMk/>
+            <pc:sldMk cId="312177612" sldId="2969"/>
+            <ac:spMk id="18" creationId="{BF75DEBA-C8B6-085A-65E7-BBBA27E3E5D7}"/>
+          </ac:spMkLst>
+        </pc:spChg>
+        <pc:spChg chg="mod">
+          <ac:chgData name="Truong, Kimberly" userId="925efed1-480b-4601-a542-5efebb98d46d" providerId="ADAL" clId="{2B89FEC1-C8C7-42CA-B874-CA36DB621456}" dt="2025-04-03T21:48:21.082" v="18" actId="2711"/>
+          <ac:spMkLst>
+            <pc:docMk/>
+            <pc:sldMk cId="312177612" sldId="2969"/>
+            <ac:spMk id="19" creationId="{ECF95AB4-396B-1A30-C8A0-A2E3F380559B}"/>
+          </ac:spMkLst>
+        </pc:spChg>
+        <pc:spChg chg="mod">
+          <ac:chgData name="Truong, Kimberly" userId="925efed1-480b-4601-a542-5efebb98d46d" providerId="ADAL" clId="{2B89FEC1-C8C7-42CA-B874-CA36DB621456}" dt="2025-04-03T21:48:21.082" v="18" actId="2711"/>
           <ac:spMkLst>
             <pc:docMk/>
             <pc:sldMk cId="312177612" sldId="2969"/>
@@ -147,7 +179,23 @@
           </ac:spMkLst>
         </pc:spChg>
         <pc:spChg chg="mod">
-          <ac:chgData name="Truong, Kimberly" userId="925efed1-480b-4601-a542-5efebb98d46d" providerId="ADAL" clId="{2B89FEC1-C8C7-42CA-B874-CA36DB621456}" dt="2025-04-03T18:38:33.325" v="16" actId="120"/>
+          <ac:chgData name="Truong, Kimberly" userId="925efed1-480b-4601-a542-5efebb98d46d" providerId="ADAL" clId="{2B89FEC1-C8C7-42CA-B874-CA36DB621456}" dt="2025-04-03T21:48:21.082" v="18" actId="2711"/>
+          <ac:spMkLst>
+            <pc:docMk/>
+            <pc:sldMk cId="312177612" sldId="2969"/>
+            <ac:spMk id="22" creationId="{1CF16134-8035-21CE-3EE6-ACE8B274FA65}"/>
+          </ac:spMkLst>
+        </pc:spChg>
+        <pc:spChg chg="mod">
+          <ac:chgData name="Truong, Kimberly" userId="925efed1-480b-4601-a542-5efebb98d46d" providerId="ADAL" clId="{2B89FEC1-C8C7-42CA-B874-CA36DB621456}" dt="2025-04-03T21:48:21.082" v="18" actId="2711"/>
+          <ac:spMkLst>
+            <pc:docMk/>
+            <pc:sldMk cId="312177612" sldId="2969"/>
+            <ac:spMk id="23" creationId="{526748DC-44E9-4212-50E3-026AD11D55E9}"/>
+          </ac:spMkLst>
+        </pc:spChg>
+        <pc:spChg chg="mod">
+          <ac:chgData name="Truong, Kimberly" userId="925efed1-480b-4601-a542-5efebb98d46d" providerId="ADAL" clId="{2B89FEC1-C8C7-42CA-B874-CA36DB621456}" dt="2025-04-03T21:49:12.719" v="21" actId="12789"/>
           <ac:spMkLst>
             <pc:docMk/>
             <pc:sldMk cId="312177612" sldId="2969"/>
@@ -155,7 +203,15 @@
           </ac:spMkLst>
         </pc:spChg>
         <pc:spChg chg="mod">
-          <ac:chgData name="Truong, Kimberly" userId="925efed1-480b-4601-a542-5efebb98d46d" providerId="ADAL" clId="{2B89FEC1-C8C7-42CA-B874-CA36DB621456}" dt="2025-04-03T18:38:33.325" v="16" actId="120"/>
+          <ac:chgData name="Truong, Kimberly" userId="925efed1-480b-4601-a542-5efebb98d46d" providerId="ADAL" clId="{2B89FEC1-C8C7-42CA-B874-CA36DB621456}" dt="2025-04-03T21:49:51.120" v="28" actId="12789"/>
+          <ac:spMkLst>
+            <pc:docMk/>
+            <pc:sldMk cId="312177612" sldId="2969"/>
+            <ac:spMk id="30" creationId="{FD89976F-3EAE-7A09-F64A-F156F72DA967}"/>
+          </ac:spMkLst>
+        </pc:spChg>
+        <pc:spChg chg="mod">
+          <ac:chgData name="Truong, Kimberly" userId="925efed1-480b-4601-a542-5efebb98d46d" providerId="ADAL" clId="{2B89FEC1-C8C7-42CA-B874-CA36DB621456}" dt="2025-04-03T21:48:21.082" v="18" actId="2711"/>
           <ac:spMkLst>
             <pc:docMk/>
             <pc:sldMk cId="312177612" sldId="2969"/>
@@ -163,7 +219,15 @@
           </ac:spMkLst>
         </pc:spChg>
         <pc:spChg chg="mod">
-          <ac:chgData name="Truong, Kimberly" userId="925efed1-480b-4601-a542-5efebb98d46d" providerId="ADAL" clId="{2B89FEC1-C8C7-42CA-B874-CA36DB621456}" dt="2025-04-03T18:38:33.325" v="16" actId="120"/>
+          <ac:chgData name="Truong, Kimberly" userId="925efed1-480b-4601-a542-5efebb98d46d" providerId="ADAL" clId="{2B89FEC1-C8C7-42CA-B874-CA36DB621456}" dt="2025-04-03T21:48:21.082" v="18" actId="2711"/>
+          <ac:spMkLst>
+            <pc:docMk/>
+            <pc:sldMk cId="312177612" sldId="2969"/>
+            <ac:spMk id="33" creationId="{A0D4AF14-9207-5C3F-B95E-049705F81C39}"/>
+          </ac:spMkLst>
+        </pc:spChg>
+        <pc:spChg chg="mod">
+          <ac:chgData name="Truong, Kimberly" userId="925efed1-480b-4601-a542-5efebb98d46d" providerId="ADAL" clId="{2B89FEC1-C8C7-42CA-B874-CA36DB621456}" dt="2025-04-03T21:48:21.082" v="18" actId="2711"/>
           <ac:spMkLst>
             <pc:docMk/>
             <pc:sldMk cId="312177612" sldId="2969"/>
@@ -171,7 +235,7 @@
           </ac:spMkLst>
         </pc:spChg>
         <pc:spChg chg="mod">
-          <ac:chgData name="Truong, Kimberly" userId="925efed1-480b-4601-a542-5efebb98d46d" providerId="ADAL" clId="{2B89FEC1-C8C7-42CA-B874-CA36DB621456}" dt="2025-04-03T18:38:51.864" v="17" actId="114"/>
+          <ac:chgData name="Truong, Kimberly" userId="925efed1-480b-4601-a542-5efebb98d46d" providerId="ADAL" clId="{2B89FEC1-C8C7-42CA-B874-CA36DB621456}" dt="2025-04-03T21:48:21.082" v="18" actId="2711"/>
           <ac:spMkLst>
             <pc:docMk/>
             <pc:sldMk cId="312177612" sldId="2969"/>
@@ -179,7 +243,15 @@
           </ac:spMkLst>
         </pc:spChg>
         <pc:spChg chg="mod">
-          <ac:chgData name="Truong, Kimberly" userId="925efed1-480b-4601-a542-5efebb98d46d" providerId="ADAL" clId="{2B89FEC1-C8C7-42CA-B874-CA36DB621456}" dt="2025-04-03T18:38:33.325" v="16" actId="120"/>
+          <ac:chgData name="Truong, Kimberly" userId="925efed1-480b-4601-a542-5efebb98d46d" providerId="ADAL" clId="{2B89FEC1-C8C7-42CA-B874-CA36DB621456}" dt="2025-04-03T21:48:21.082" v="18" actId="2711"/>
+          <ac:spMkLst>
+            <pc:docMk/>
+            <pc:sldMk cId="312177612" sldId="2969"/>
+            <ac:spMk id="46" creationId="{87D014D5-3C9B-AA73-744A-0A1FF7E0B979}"/>
+          </ac:spMkLst>
+        </pc:spChg>
+        <pc:spChg chg="mod">
+          <ac:chgData name="Truong, Kimberly" userId="925efed1-480b-4601-a542-5efebb98d46d" providerId="ADAL" clId="{2B89FEC1-C8C7-42CA-B874-CA36DB621456}" dt="2025-04-03T21:48:21.082" v="18" actId="2711"/>
           <ac:spMkLst>
             <pc:docMk/>
             <pc:sldMk cId="312177612" sldId="2969"/>
@@ -187,7 +259,31 @@
           </ac:spMkLst>
         </pc:spChg>
         <pc:spChg chg="mod">
-          <ac:chgData name="Truong, Kimberly" userId="925efed1-480b-4601-a542-5efebb98d46d" providerId="ADAL" clId="{2B89FEC1-C8C7-42CA-B874-CA36DB621456}" dt="2025-04-03T18:38:33.325" v="16" actId="120"/>
+          <ac:chgData name="Truong, Kimberly" userId="925efed1-480b-4601-a542-5efebb98d46d" providerId="ADAL" clId="{2B89FEC1-C8C7-42CA-B874-CA36DB621456}" dt="2025-04-03T21:48:21.082" v="18" actId="2711"/>
+          <ac:spMkLst>
+            <pc:docMk/>
+            <pc:sldMk cId="312177612" sldId="2969"/>
+            <ac:spMk id="56" creationId="{DE392B63-A87D-C137-5D27-F324F8012606}"/>
+          </ac:spMkLst>
+        </pc:spChg>
+        <pc:spChg chg="mod">
+          <ac:chgData name="Truong, Kimberly" userId="925efed1-480b-4601-a542-5efebb98d46d" providerId="ADAL" clId="{2B89FEC1-C8C7-42CA-B874-CA36DB621456}" dt="2025-04-03T21:48:21.082" v="18" actId="2711"/>
+          <ac:spMkLst>
+            <pc:docMk/>
+            <pc:sldMk cId="312177612" sldId="2969"/>
+            <ac:spMk id="57" creationId="{5C52125C-8ED8-7A5A-7DFD-C7FCDEED2B89}"/>
+          </ac:spMkLst>
+        </pc:spChg>
+        <pc:spChg chg="mod">
+          <ac:chgData name="Truong, Kimberly" userId="925efed1-480b-4601-a542-5efebb98d46d" providerId="ADAL" clId="{2B89FEC1-C8C7-42CA-B874-CA36DB621456}" dt="2025-04-03T21:49:51.120" v="28" actId="12789"/>
+          <ac:spMkLst>
+            <pc:docMk/>
+            <pc:sldMk cId="312177612" sldId="2969"/>
+            <ac:spMk id="77" creationId="{242C9CC5-770B-DEAA-D76C-9F1173E32D87}"/>
+          </ac:spMkLst>
+        </pc:spChg>
+        <pc:spChg chg="mod">
+          <ac:chgData name="Truong, Kimberly" userId="925efed1-480b-4601-a542-5efebb98d46d" providerId="ADAL" clId="{2B89FEC1-C8C7-42CA-B874-CA36DB621456}" dt="2025-04-03T21:48:21.082" v="18" actId="2711"/>
           <ac:spMkLst>
             <pc:docMk/>
             <pc:sldMk cId="312177612" sldId="2969"/>
@@ -203,13 +299,21 @@
           </ac:graphicFrameMkLst>
         </pc:graphicFrameChg>
         <pc:graphicFrameChg chg="mod">
-          <ac:chgData name="Truong, Kimberly" userId="925efed1-480b-4601-a542-5efebb98d46d" providerId="ADAL" clId="{2B89FEC1-C8C7-42CA-B874-CA36DB621456}" dt="2025-04-03T18:37:17.974" v="5" actId="207"/>
+          <ac:chgData name="Truong, Kimberly" userId="925efed1-480b-4601-a542-5efebb98d46d" providerId="ADAL" clId="{2B89FEC1-C8C7-42CA-B874-CA36DB621456}" dt="2025-04-03T21:51:27.729" v="38" actId="2085"/>
           <ac:graphicFrameMkLst>
             <pc:docMk/>
             <pc:sldMk cId="312177612" sldId="2969"/>
             <ac:graphicFrameMk id="24" creationId="{EFF69940-0D6D-5518-442B-DBCC36EF3D3C}"/>
           </ac:graphicFrameMkLst>
         </pc:graphicFrameChg>
+        <pc:cxnChg chg="mod">
+          <ac:chgData name="Truong, Kimberly" userId="925efed1-480b-4601-a542-5efebb98d46d" providerId="ADAL" clId="{2B89FEC1-C8C7-42CA-B874-CA36DB621456}" dt="2025-04-03T21:50:00.887" v="32" actId="1036"/>
+          <ac:cxnSpMkLst>
+            <pc:docMk/>
+            <pc:sldMk cId="312177612" sldId="2969"/>
+            <ac:cxnSpMk id="89" creationId="{250BF3FB-AF8B-26FD-9AC5-2F679DA732BA}"/>
+          </ac:cxnSpMkLst>
+        </pc:cxnChg>
       </pc:sldChg>
     </pc:docChg>
   </pc:docChgLst>
@@ -1104,6 +1208,9 @@
         <a:solidFill>
           <a:srgbClr val="A4C0E3"/>
         </a:solidFill>
+        <a:ln>
+          <a:noFill/>
+        </a:ln>
       </dgm:spPr>
       <dgm:t>
         <a:bodyPr/>
@@ -1118,7 +1225,7 @@
                   </a:srgbClr>
                 </a:outerShdw>
               </a:effectLst>
-              <a:latin typeface="Aptos" panose="020B0004020202020204" pitchFamily="34" charset="0"/>
+              <a:latin typeface="Avenir Next LT Pro" panose="020B0504020202020204" pitchFamily="34" charset="0"/>
               <a:cs typeface="Arial" panose="020B0604020202020204" pitchFamily="34" charset="0"/>
             </a:rPr>
             <a:t> 1. Assay Data Compilation</a:t>
@@ -1160,6 +1267,9 @@
         <a:solidFill>
           <a:srgbClr val="88AED8"/>
         </a:solidFill>
+        <a:ln>
+          <a:noFill/>
+        </a:ln>
       </dgm:spPr>
       <dgm:t>
         <a:bodyPr/>
@@ -1174,7 +1284,7 @@
                   </a:srgbClr>
                 </a:outerShdw>
               </a:effectLst>
-              <a:latin typeface="Aptos" panose="020B0004020202020204" pitchFamily="34" charset="0"/>
+              <a:latin typeface="Avenir Next LT Pro" panose="020B0504020202020204" pitchFamily="34" charset="0"/>
               <a:cs typeface="Arial" panose="020B0604020202020204" pitchFamily="34" charset="0"/>
             </a:rPr>
             <a:t>2. Assessment for Selectivity + Assay Interference</a:t>
@@ -1216,6 +1326,9 @@
         <a:solidFill>
           <a:srgbClr val="6D9DCD"/>
         </a:solidFill>
+        <a:ln>
+          <a:noFill/>
+        </a:ln>
       </dgm:spPr>
       <dgm:t>
         <a:bodyPr/>
@@ -1230,7 +1343,7 @@
                   </a:srgbClr>
                 </a:outerShdw>
               </a:effectLst>
-              <a:latin typeface="Aptos" panose="020B0004020202020204" pitchFamily="34" charset="0"/>
+              <a:latin typeface="Avenir Next LT Pro" panose="020B0504020202020204" pitchFamily="34" charset="0"/>
               <a:cs typeface="Arial" panose="020B0604020202020204" pitchFamily="34" charset="0"/>
             </a:rPr>
             <a:t>3. Refinement</a:t>
@@ -1272,6 +1385,9 @@
         <a:solidFill>
           <a:srgbClr val="528CC1"/>
         </a:solidFill>
+        <a:ln>
+          <a:noFill/>
+        </a:ln>
       </dgm:spPr>
       <dgm:t>
         <a:bodyPr/>
@@ -1286,7 +1402,7 @@
                   </a:srgbClr>
                 </a:outerShdw>
               </a:effectLst>
-              <a:latin typeface="Aptos" panose="020B0004020202020204" pitchFamily="34" charset="0"/>
+              <a:latin typeface="Avenir Next LT Pro" panose="020B0504020202020204" pitchFamily="34" charset="0"/>
               <a:cs typeface="Arial" panose="020B0604020202020204" pitchFamily="34" charset="0"/>
             </a:rPr>
             <a:t>4. Targeted bioactivity: exposure ratios</a:t>
@@ -1441,14 +1557,7 @@
           <a:srgbClr val="A4C0E3"/>
         </a:solidFill>
         <a:ln w="12700" cap="flat" cmpd="sng" algn="ctr">
-          <a:solidFill>
-            <a:schemeClr val="lt1">
-              <a:hueOff val="0"/>
-              <a:satOff val="0"/>
-              <a:lumOff val="0"/>
-              <a:alphaOff val="0"/>
-            </a:schemeClr>
-          </a:solidFill>
+          <a:noFill/>
           <a:prstDash val="solid"/>
           <a:miter lim="800000"/>
         </a:ln>
@@ -1495,7 +1604,7 @@
                   </a:srgbClr>
                 </a:outerShdw>
               </a:effectLst>
-              <a:latin typeface="Aptos" panose="020B0004020202020204" pitchFamily="34" charset="0"/>
+              <a:latin typeface="Avenir Next LT Pro" panose="020B0504020202020204" pitchFamily="34" charset="0"/>
               <a:cs typeface="Arial" panose="020B0604020202020204" pitchFamily="34" charset="0"/>
             </a:rPr>
             <a:t> 1. Assay Data Compilation</a:t>
@@ -1524,14 +1633,7 @@
           <a:srgbClr val="88AED8"/>
         </a:solidFill>
         <a:ln w="12700" cap="flat" cmpd="sng" algn="ctr">
-          <a:solidFill>
-            <a:schemeClr val="lt1">
-              <a:hueOff val="0"/>
-              <a:satOff val="0"/>
-              <a:lumOff val="0"/>
-              <a:alphaOff val="0"/>
-            </a:schemeClr>
-          </a:solidFill>
+          <a:noFill/>
           <a:prstDash val="solid"/>
           <a:miter lim="800000"/>
         </a:ln>
@@ -1578,7 +1680,7 @@
                   </a:srgbClr>
                 </a:outerShdw>
               </a:effectLst>
-              <a:latin typeface="Aptos" panose="020B0004020202020204" pitchFamily="34" charset="0"/>
+              <a:latin typeface="Avenir Next LT Pro" panose="020B0504020202020204" pitchFamily="34" charset="0"/>
               <a:cs typeface="Arial" panose="020B0604020202020204" pitchFamily="34" charset="0"/>
             </a:rPr>
             <a:t>2. Assessment for Selectivity + Assay Interference</a:t>
@@ -1607,14 +1709,7 @@
           <a:srgbClr val="6D9DCD"/>
         </a:solidFill>
         <a:ln w="12700" cap="flat" cmpd="sng" algn="ctr">
-          <a:solidFill>
-            <a:schemeClr val="lt1">
-              <a:hueOff val="0"/>
-              <a:satOff val="0"/>
-              <a:lumOff val="0"/>
-              <a:alphaOff val="0"/>
-            </a:schemeClr>
-          </a:solidFill>
+          <a:noFill/>
           <a:prstDash val="solid"/>
           <a:miter lim="800000"/>
         </a:ln>
@@ -1661,7 +1756,7 @@
                   </a:srgbClr>
                 </a:outerShdw>
               </a:effectLst>
-              <a:latin typeface="Aptos" panose="020B0004020202020204" pitchFamily="34" charset="0"/>
+              <a:latin typeface="Avenir Next LT Pro" panose="020B0504020202020204" pitchFamily="34" charset="0"/>
               <a:cs typeface="Arial" panose="020B0604020202020204" pitchFamily="34" charset="0"/>
             </a:rPr>
             <a:t>3. Refinement</a:t>
@@ -1690,14 +1785,7 @@
           <a:srgbClr val="528CC1"/>
         </a:solidFill>
         <a:ln w="12700" cap="flat" cmpd="sng" algn="ctr">
-          <a:solidFill>
-            <a:schemeClr val="lt1">
-              <a:hueOff val="0"/>
-              <a:satOff val="0"/>
-              <a:lumOff val="0"/>
-              <a:alphaOff val="0"/>
-            </a:schemeClr>
-          </a:solidFill>
+          <a:noFill/>
           <a:prstDash val="solid"/>
           <a:miter lim="800000"/>
         </a:ln>
@@ -1744,7 +1832,7 @@
                   </a:srgbClr>
                 </a:outerShdw>
               </a:effectLst>
-              <a:latin typeface="Aptos" panose="020B0004020202020204" pitchFamily="34" charset="0"/>
+              <a:latin typeface="Avenir Next LT Pro" panose="020B0504020202020204" pitchFamily="34" charset="0"/>
               <a:cs typeface="Arial" panose="020B0604020202020204" pitchFamily="34" charset="0"/>
             </a:rPr>
             <a:t>4. Targeted bioactivity: exposure ratios</a:t>
@@ -6789,7 +6877,7 @@
             <p:ph idx="1"/>
             <p:extLst>
               <p:ext uri="{D42A27DB-BD31-4B8C-83A1-F6EECF244321}">
-                <p14:modId xmlns:p14="http://schemas.microsoft.com/office/powerpoint/2010/main" val="2419759159"/>
+                <p14:modId xmlns:p14="http://schemas.microsoft.com/office/powerpoint/2010/main" val="1758109854"/>
               </p:ext>
             </p:extLst>
           </p:nvPr>
@@ -6834,34 +6922,34 @@
           <a:p>
             <a:r>
               <a:rPr lang="en-US" sz="1400" dirty="0">
-                <a:latin typeface="Aptos" panose="020B0004020202020204" pitchFamily="34" charset="0"/>
+                <a:latin typeface="Avenir Next LT Pro" panose="020B0504020202020204" pitchFamily="34" charset="0"/>
                 <a:cs typeface="Calibri" panose="020F0502020204030204" pitchFamily="34" charset="0"/>
               </a:rPr>
               <a:t>17 chemicals with no </a:t>
             </a:r>
             <a:r>
               <a:rPr lang="en-US" sz="1400" i="1" dirty="0">
-                <a:latin typeface="Aptos" panose="020B0004020202020204" pitchFamily="34" charset="0"/>
+                <a:latin typeface="Avenir Next LT Pro" panose="020B0504020202020204" pitchFamily="34" charset="0"/>
                 <a:cs typeface="Calibri" panose="020F0502020204030204" pitchFamily="34" charset="0"/>
               </a:rPr>
               <a:t>in vitro </a:t>
             </a:r>
             <a:r>
               <a:rPr lang="en-US" sz="1400" dirty="0">
-                <a:latin typeface="Aptos" panose="020B0004020202020204" pitchFamily="34" charset="0"/>
+                <a:latin typeface="Avenir Next LT Pro" panose="020B0504020202020204" pitchFamily="34" charset="0"/>
                 <a:cs typeface="Calibri" panose="020F0502020204030204" pitchFamily="34" charset="0"/>
               </a:rPr>
               <a:t>toxicokinetic parameters for </a:t>
             </a:r>
             <a:r>
               <a:rPr lang="en-US" sz="1400" i="1" dirty="0" err="1">
-                <a:latin typeface="Aptos" panose="020B0004020202020204" pitchFamily="34" charset="0"/>
+                <a:latin typeface="Avenir Next LT Pro" panose="020B0504020202020204" pitchFamily="34" charset="0"/>
                 <a:cs typeface="Calibri" panose="020F0502020204030204" pitchFamily="34" charset="0"/>
               </a:rPr>
               <a:t>httk</a:t>
             </a:r>
             <a:endParaRPr lang="en-US" sz="1400" i="1" dirty="0">
-              <a:latin typeface="Aptos" panose="020B0004020202020204" pitchFamily="34" charset="0"/>
+              <a:latin typeface="Avenir Next LT Pro" panose="020B0504020202020204" pitchFamily="34" charset="0"/>
               <a:cs typeface="Calibri" panose="020F0502020204030204" pitchFamily="34" charset="0"/>
             </a:endParaRPr>
           </a:p>
@@ -6922,7 +7010,9 @@
           <a:lstStyle/>
           <a:p>
             <a:pPr algn="ctr"/>
-            <a:endParaRPr lang="en-US"/>
+            <a:endParaRPr lang="en-US">
+              <a:latin typeface="Avenir Next LT Pro" panose="020B0504020202020204" pitchFamily="34" charset="0"/>
+            </a:endParaRPr>
           </a:p>
         </p:txBody>
       </p:sp>
@@ -6981,7 +7071,9 @@
           <a:lstStyle/>
           <a:p>
             <a:pPr algn="ctr"/>
-            <a:endParaRPr lang="en-US"/>
+            <a:endParaRPr lang="en-US">
+              <a:latin typeface="Avenir Next LT Pro" panose="020B0504020202020204" pitchFamily="34" charset="0"/>
+            </a:endParaRPr>
           </a:p>
         </p:txBody>
       </p:sp>
@@ -7040,7 +7132,9 @@
           <a:lstStyle/>
           <a:p>
             <a:pPr algn="ctr"/>
-            <a:endParaRPr lang="en-US" dirty="0"/>
+            <a:endParaRPr lang="en-US" dirty="0">
+              <a:latin typeface="Avenir Next LT Pro" panose="020B0504020202020204" pitchFamily="34" charset="0"/>
+            </a:endParaRPr>
           </a:p>
         </p:txBody>
       </p:sp>
@@ -7074,7 +7168,7 @@
           <a:p>
             <a:r>
               <a:rPr lang="en-US" sz="1600" dirty="0">
-                <a:latin typeface="Aptos" panose="020B0004020202020204" pitchFamily="34" charset="0"/>
+                <a:latin typeface="Avenir Next LT Pro" panose="020B0504020202020204" pitchFamily="34" charset="0"/>
               </a:rPr>
               <a:t>285 Positive Chemicals</a:t>
             </a:r>
@@ -7111,18 +7205,18 @@
           <a:p>
             <a:r>
               <a:rPr lang="en-US" dirty="0">
-                <a:latin typeface="Aptos" panose="020B0004020202020204" pitchFamily="34" charset="0"/>
+                <a:latin typeface="Avenir Next LT Pro" panose="020B0504020202020204" pitchFamily="34" charset="0"/>
               </a:rPr>
               <a:t> </a:t>
             </a:r>
             <a:r>
               <a:rPr lang="en-US" sz="1600" dirty="0">
-                <a:latin typeface="Aptos" panose="020B0004020202020204" pitchFamily="34" charset="0"/>
+                <a:latin typeface="Avenir Next LT Pro" panose="020B0504020202020204" pitchFamily="34" charset="0"/>
               </a:rPr>
               <a:t>135 Chemicals</a:t>
             </a:r>
             <a:endParaRPr lang="en-US" dirty="0">
-              <a:latin typeface="Aptos" panose="020B0004020202020204" pitchFamily="34" charset="0"/>
+              <a:latin typeface="Avenir Next LT Pro" panose="020B0504020202020204" pitchFamily="34" charset="0"/>
             </a:endParaRPr>
           </a:p>
         </p:txBody>
@@ -7157,7 +7251,7 @@
           <a:p>
             <a:r>
               <a:rPr lang="en-US" sz="1600" dirty="0">
-                <a:latin typeface="Aptos" panose="020B0004020202020204" pitchFamily="34" charset="0"/>
+                <a:latin typeface="Avenir Next LT Pro" panose="020B0504020202020204" pitchFamily="34" charset="0"/>
               </a:rPr>
               <a:t>120 Chemicals</a:t>
             </a:r>
@@ -7219,7 +7313,9 @@
           <a:lstStyle/>
           <a:p>
             <a:pPr algn="ctr"/>
-            <a:endParaRPr lang="en-US" dirty="0"/>
+            <a:endParaRPr lang="en-US" dirty="0">
+              <a:latin typeface="Avenir Next LT Pro" panose="020B0504020202020204" pitchFamily="34" charset="0"/>
+            </a:endParaRPr>
           </a:p>
         </p:txBody>
       </p:sp>
@@ -7253,7 +7349,7 @@
           <a:p>
             <a:r>
               <a:rPr lang="en-US" sz="1600" dirty="0">
-                <a:latin typeface="Aptos" panose="020B0004020202020204" pitchFamily="34" charset="0"/>
+                <a:latin typeface="Avenir Next LT Pro" panose="020B0504020202020204" pitchFamily="34" charset="0"/>
               </a:rPr>
               <a:t>103 Chemicals</a:t>
             </a:r>
@@ -7291,7 +7387,7 @@
             <a:pPr algn="ctr"/>
             <a:r>
               <a:rPr lang="en-US" sz="1400" dirty="0">
-                <a:latin typeface="Aptos" panose="020B0004020202020204" pitchFamily="34" charset="0"/>
+                <a:latin typeface="Avenir Next LT Pro" panose="020B0504020202020204" pitchFamily="34" charset="0"/>
               </a:rPr>
               <a:t>Verify “selectivity” even for cell-free assays </a:t>
             </a:r>
@@ -7334,7 +7430,7 @@
                 <a:solidFill>
                   <a:prstClr val="black"/>
                 </a:solidFill>
-                <a:latin typeface="Aptos" panose="020B0004020202020204" pitchFamily="34" charset="0"/>
+                <a:latin typeface="Avenir Next LT Pro" panose="020B0504020202020204" pitchFamily="34" charset="0"/>
                 <a:cs typeface="Calibri" panose="020F0502020204030204" pitchFamily="34" charset="0"/>
               </a:rPr>
               <a:t>49 DIO1 inhibitors, </a:t>
@@ -7349,7 +7445,7 @@
                 <a:solidFill>
                   <a:prstClr val="black"/>
                 </a:solidFill>
-                <a:latin typeface="Aptos" panose="020B0004020202020204" pitchFamily="34" charset="0"/>
+                <a:latin typeface="Avenir Next LT Pro" panose="020B0504020202020204" pitchFamily="34" charset="0"/>
                 <a:cs typeface="Calibri" panose="020F0502020204030204" pitchFamily="34" charset="0"/>
               </a:rPr>
               <a:t>55 DIO2 inhibitors, </a:t>
@@ -7364,7 +7460,7 @@
                 <a:solidFill>
                   <a:prstClr val="black"/>
                 </a:solidFill>
-                <a:latin typeface="Aptos" panose="020B0004020202020204" pitchFamily="34" charset="0"/>
+                <a:latin typeface="Avenir Next LT Pro" panose="020B0504020202020204" pitchFamily="34" charset="0"/>
                 <a:cs typeface="Calibri" panose="020F0502020204030204" pitchFamily="34" charset="0"/>
               </a:rPr>
               <a:t>79 DIO3 inhibitors, </a:t>
@@ -7379,7 +7475,7 @@
                 <a:solidFill>
                   <a:prstClr val="black"/>
                 </a:solidFill>
-                <a:latin typeface="Aptos" panose="020B0004020202020204" pitchFamily="34" charset="0"/>
+                <a:latin typeface="Avenir Next LT Pro" panose="020B0504020202020204" pitchFamily="34" charset="0"/>
                 <a:cs typeface="Calibri" panose="020F0502020204030204" pitchFamily="34" charset="0"/>
               </a:rPr>
               <a:t>12 IYD inhibitors</a:t>
@@ -7402,7 +7498,7 @@
         <p:spPr>
           <a:xfrm>
             <a:off x="849984" y="1901626"/>
-            <a:ext cx="2357494" cy="523220"/>
+            <a:ext cx="2426346" cy="523220"/>
           </a:xfrm>
           <a:prstGeom prst="rect">
             <a:avLst/>
@@ -7418,19 +7514,19 @@
             <a:pPr algn="ctr"/>
             <a:r>
               <a:rPr lang="en-US" sz="1400" dirty="0">
-                <a:latin typeface="Aptos" panose="020B0004020202020204" pitchFamily="34" charset="0"/>
+                <a:latin typeface="Avenir Next LT Pro" panose="020B0504020202020204" pitchFamily="34" charset="0"/>
               </a:rPr>
               <a:t>2007 total chemicals screened in single-conc (</a:t>
             </a:r>
             <a:r>
               <a:rPr lang="en-US" sz="1400" dirty="0" err="1">
-                <a:latin typeface="Aptos" panose="020B0004020202020204" pitchFamily="34" charset="0"/>
+                <a:latin typeface="Avenir Next LT Pro" panose="020B0504020202020204" pitchFamily="34" charset="0"/>
               </a:rPr>
               <a:t>sc</a:t>
             </a:r>
             <a:r>
               <a:rPr lang="en-US" sz="1400" dirty="0">
-                <a:latin typeface="Aptos" panose="020B0004020202020204" pitchFamily="34" charset="0"/>
+                <a:latin typeface="Avenir Next LT Pro" panose="020B0504020202020204" pitchFamily="34" charset="0"/>
               </a:rPr>
               <a:t>)</a:t>
             </a:r>
@@ -7451,7 +7547,7 @@
         </p:nvSpPr>
         <p:spPr>
           <a:xfrm flipV="1">
-            <a:off x="1915430" y="2486176"/>
+            <a:off x="1915430" y="2496664"/>
             <a:ext cx="198404" cy="173049"/>
           </a:xfrm>
           <a:prstGeom prst="triangle">
@@ -7479,7 +7575,9 @@
           <a:lstStyle/>
           <a:p>
             <a:pPr algn="ctr"/>
-            <a:endParaRPr lang="en-US"/>
+            <a:endParaRPr lang="en-US">
+              <a:latin typeface="Avenir Next LT Pro" panose="020B0504020202020204" pitchFamily="34" charset="0"/>
+            </a:endParaRPr>
           </a:p>
         </p:txBody>
       </p:sp>
@@ -7514,7 +7612,7 @@
             <a:pPr algn="ctr"/>
             <a:r>
               <a:rPr lang="en-US" sz="1400" dirty="0">
-                <a:latin typeface="Aptos" panose="020B0004020202020204" pitchFamily="34" charset="0"/>
+                <a:latin typeface="Avenir Next LT Pro" panose="020B0504020202020204" pitchFamily="34" charset="0"/>
               </a:rPr>
               <a:t>523 chemicals with &gt;20% inhibition in at least one assay</a:t>
             </a:r>
@@ -7563,7 +7661,9 @@
           <a:lstStyle/>
           <a:p>
             <a:pPr algn="ctr"/>
-            <a:endParaRPr lang="en-US"/>
+            <a:endParaRPr lang="en-US">
+              <a:latin typeface="Avenir Next LT Pro" panose="020B0504020202020204" pitchFamily="34" charset="0"/>
+            </a:endParaRPr>
           </a:p>
         </p:txBody>
       </p:sp>
@@ -7598,7 +7698,7 @@
             <a:pPr algn="ctr"/>
             <a:r>
               <a:rPr lang="en-US" sz="1400" dirty="0">
-                <a:latin typeface="Aptos" panose="020B0004020202020204" pitchFamily="34" charset="0"/>
+                <a:latin typeface="Avenir Next LT Pro" panose="020B0504020202020204" pitchFamily="34" charset="0"/>
               </a:rPr>
               <a:t>327 chemicals screened in multi-conc (mc) </a:t>
             </a:r>
@@ -7647,7 +7747,9 @@
           <a:lstStyle/>
           <a:p>
             <a:pPr algn="ctr"/>
-            <a:endParaRPr lang="en-US"/>
+            <a:endParaRPr lang="en-US">
+              <a:latin typeface="Avenir Next LT Pro" panose="020B0504020202020204" pitchFamily="34" charset="0"/>
+            </a:endParaRPr>
           </a:p>
         </p:txBody>
       </p:sp>
@@ -7682,7 +7784,7 @@
             <a:pPr algn="ctr"/>
             <a:r>
               <a:rPr lang="en-US" sz="1400" dirty="0">
-                <a:latin typeface="Aptos" panose="020B0004020202020204" pitchFamily="34" charset="0"/>
+                <a:latin typeface="Avenir Next LT Pro" panose="020B0504020202020204" pitchFamily="34" charset="0"/>
               </a:rPr>
               <a:t>Prioritization based on maternal-fetal exposure using HTTK</a:t>
             </a:r>
@@ -7873,7 +7975,7 @@
         </p:nvSpPr>
         <p:spPr>
           <a:xfrm flipV="1">
-            <a:off x="4476934" y="2507152"/>
+            <a:off x="4476934" y="2496664"/>
             <a:ext cx="198404" cy="173049"/>
           </a:xfrm>
           <a:prstGeom prst="triangle">
@@ -7901,7 +8003,9 @@
           <a:lstStyle/>
           <a:p>
             <a:pPr algn="ctr"/>
-            <a:endParaRPr lang="en-US"/>
+            <a:endParaRPr lang="en-US">
+              <a:latin typeface="Avenir Next LT Pro" panose="020B0504020202020204" pitchFamily="34" charset="0"/>
+            </a:endParaRPr>
           </a:p>
         </p:txBody>
       </p:sp>
@@ -7920,7 +8024,7 @@
         <p:spPr>
           <a:xfrm>
             <a:off x="3443777" y="2762506"/>
-            <a:ext cx="2343571" cy="523220"/>
+            <a:ext cx="2343571" cy="738664"/>
           </a:xfrm>
           <a:prstGeom prst="rect">
             <a:avLst/>
@@ -7936,7 +8040,7 @@
             <a:pPr algn="ctr"/>
             <a:r>
               <a:rPr lang="en-US" sz="1400" dirty="0">
-                <a:latin typeface="Aptos" panose="020B0004020202020204" pitchFamily="34" charset="0"/>
+                <a:latin typeface="Avenir Next LT Pro" panose="020B0504020202020204" pitchFamily="34" charset="0"/>
               </a:rPr>
               <a:t>Filter for sources of assay interference or pan-activity</a:t>
             </a:r>

</xml_diff>

<commit_message>
center-aligning everything is better
</commit_message>
<xml_diff>
--- a/figures/fig1-workflow.pptx
+++ b/figures/fig1-workflow.pptx
@@ -120,18 +120,18 @@
   <pc:docChgLst>
     <pc:chgData name="Truong, Kimberly" userId="925efed1-480b-4601-a542-5efebb98d46d" providerId="ADAL" clId="{2B89FEC1-C8C7-42CA-B874-CA36DB621456}"/>
     <pc:docChg chg="undo redo custSel modSld">
-      <pc:chgData name="Truong, Kimberly" userId="925efed1-480b-4601-a542-5efebb98d46d" providerId="ADAL" clId="{2B89FEC1-C8C7-42CA-B874-CA36DB621456}" dt="2025-04-03T22:03:20.480" v="88" actId="554"/>
+      <pc:chgData name="Truong, Kimberly" userId="925efed1-480b-4601-a542-5efebb98d46d" providerId="ADAL" clId="{2B89FEC1-C8C7-42CA-B874-CA36DB621456}" dt="2025-04-03T22:07:58.489" v="89" actId="122"/>
       <pc:docMkLst>
         <pc:docMk/>
       </pc:docMkLst>
       <pc:sldChg chg="addSp delSp modSp mod">
-        <pc:chgData name="Truong, Kimberly" userId="925efed1-480b-4601-a542-5efebb98d46d" providerId="ADAL" clId="{2B89FEC1-C8C7-42CA-B874-CA36DB621456}" dt="2025-04-03T22:03:20.480" v="88" actId="554"/>
+        <pc:chgData name="Truong, Kimberly" userId="925efed1-480b-4601-a542-5efebb98d46d" providerId="ADAL" clId="{2B89FEC1-C8C7-42CA-B874-CA36DB621456}" dt="2025-04-03T22:07:58.489" v="89" actId="122"/>
         <pc:sldMkLst>
           <pc:docMk/>
           <pc:sldMk cId="312177612" sldId="2969"/>
         </pc:sldMkLst>
         <pc:spChg chg="mod">
-          <ac:chgData name="Truong, Kimberly" userId="925efed1-480b-4601-a542-5efebb98d46d" providerId="ADAL" clId="{2B89FEC1-C8C7-42CA-B874-CA36DB621456}" dt="2025-04-03T22:03:20.480" v="88" actId="554"/>
+          <ac:chgData name="Truong, Kimberly" userId="925efed1-480b-4601-a542-5efebb98d46d" providerId="ADAL" clId="{2B89FEC1-C8C7-42CA-B874-CA36DB621456}" dt="2025-04-03T22:07:58.489" v="89" actId="122"/>
           <ac:spMkLst>
             <pc:docMk/>
             <pc:sldMk cId="312177612" sldId="2969"/>
@@ -171,7 +171,7 @@
           </ac:spMkLst>
         </pc:spChg>
         <pc:spChg chg="mod">
-          <ac:chgData name="Truong, Kimberly" userId="925efed1-480b-4601-a542-5efebb98d46d" providerId="ADAL" clId="{2B89FEC1-C8C7-42CA-B874-CA36DB621456}" dt="2025-04-03T22:03:20.480" v="88" actId="554"/>
+          <ac:chgData name="Truong, Kimberly" userId="925efed1-480b-4601-a542-5efebb98d46d" providerId="ADAL" clId="{2B89FEC1-C8C7-42CA-B874-CA36DB621456}" dt="2025-04-03T22:07:58.489" v="89" actId="122"/>
           <ac:spMkLst>
             <pc:docMk/>
             <pc:sldMk cId="312177612" sldId="2969"/>
@@ -251,7 +251,7 @@
           </ac:spMkLst>
         </pc:spChg>
         <pc:spChg chg="mod">
-          <ac:chgData name="Truong, Kimberly" userId="925efed1-480b-4601-a542-5efebb98d46d" providerId="ADAL" clId="{2B89FEC1-C8C7-42CA-B874-CA36DB621456}" dt="2025-04-03T22:03:20.480" v="88" actId="554"/>
+          <ac:chgData name="Truong, Kimberly" userId="925efed1-480b-4601-a542-5efebb98d46d" providerId="ADAL" clId="{2B89FEC1-C8C7-42CA-B874-CA36DB621456}" dt="2025-04-03T22:07:58.489" v="89" actId="122"/>
           <ac:spMkLst>
             <pc:docMk/>
             <pc:sldMk cId="312177612" sldId="2969"/>
@@ -283,7 +283,7 @@
           </ac:spMkLst>
         </pc:spChg>
         <pc:spChg chg="mod">
-          <ac:chgData name="Truong, Kimberly" userId="925efed1-480b-4601-a542-5efebb98d46d" providerId="ADAL" clId="{2B89FEC1-C8C7-42CA-B874-CA36DB621456}" dt="2025-04-03T22:02:16.762" v="83" actId="12788"/>
+          <ac:chgData name="Truong, Kimberly" userId="925efed1-480b-4601-a542-5efebb98d46d" providerId="ADAL" clId="{2B89FEC1-C8C7-42CA-B874-CA36DB621456}" dt="2025-04-03T22:07:58.489" v="89" actId="122"/>
           <ac:spMkLst>
             <pc:docMk/>
             <pc:sldMk cId="312177612" sldId="2969"/>
@@ -7384,6 +7384,7 @@
           </a:bodyPr>
           <a:lstStyle/>
           <a:p>
+            <a:pPr algn="ctr"/>
             <a:r>
               <a:rPr lang="en-US" sz="1400" dirty="0">
                 <a:latin typeface="Avenir Next LT Pro" panose="020B0504020202020204" pitchFamily="34" charset="0"/>
@@ -7421,7 +7422,7 @@
           </a:bodyPr>
           <a:lstStyle/>
           <a:p>
-            <a:pPr defTabSz="914411">
+            <a:pPr algn="ctr" defTabSz="914411">
               <a:defRPr/>
             </a:pPr>
             <a:r>
@@ -7436,7 +7437,7 @@
             </a:r>
           </a:p>
           <a:p>
-            <a:pPr defTabSz="914411">
+            <a:pPr algn="ctr" defTabSz="914411">
               <a:defRPr/>
             </a:pPr>
             <a:r>
@@ -7451,7 +7452,7 @@
             </a:r>
           </a:p>
           <a:p>
-            <a:pPr defTabSz="914411">
+            <a:pPr algn="ctr" defTabSz="914411">
               <a:defRPr/>
             </a:pPr>
             <a:r>
@@ -7466,7 +7467,7 @@
             </a:r>
           </a:p>
           <a:p>
-            <a:pPr defTabSz="914411">
+            <a:pPr algn="ctr" defTabSz="914411">
               <a:defRPr/>
             </a:pPr>
             <a:r>
@@ -7780,6 +7781,7 @@
           </a:bodyPr>
           <a:lstStyle/>
           <a:p>
+            <a:pPr algn="ctr"/>
             <a:r>
               <a:rPr lang="en-US" sz="1400" dirty="0">
                 <a:latin typeface="Avenir Next LT Pro" panose="020B0504020202020204" pitchFamily="34" charset="0"/>
@@ -8035,6 +8037,7 @@
           </a:bodyPr>
           <a:lstStyle/>
           <a:p>
+            <a:pPr algn="ctr"/>
             <a:r>
               <a:rPr lang="en-US" sz="1400" dirty="0">
                 <a:latin typeface="Avenir Next LT Pro" panose="020B0504020202020204" pitchFamily="34" charset="0"/>

</xml_diff>